<commit_message>
Consolidate figures/tables: move glucose-control prism and LOO to supplementary
Co-Authored-By: Tatsuki Onishi <bougtoir@gmail.com>
</commit_message>
<xml_diff>
--- a/icr_paper/LINKO_figures_english.pptx
+++ b/icr_paper/LINKO_figures_english.pptx
@@ -3549,7 +3549,7 @@
                 </a:solidFill>
                 <a:latin typeface="Calibri"/>
               </a:rPr>
-              <a:t>Figure 4</a:t>
+              <a:t>Supplementary Figure S1</a:t>
             </a:r>
           </a:p>
         </p:txBody>
@@ -3608,7 +3608,7 @@
                 </a:solidFill>
                 <a:latin typeface="Calibri"/>
               </a:rPr>
-              <a:t>Figure 4. Prism forest plot for the intensive glucose-control collection.</a:t>
+              <a:t>Supplementary Figure S1. Prism forest plot for the intensive glucose-control collection.</a:t>
             </a:r>
           </a:p>
         </p:txBody>
@@ -3661,7 +3661,7 @@
                 </a:solidFill>
                 <a:latin typeface="Calibri"/>
               </a:rPr>
-              <a:t>Figure 5</a:t>
+              <a:t>Figure 4</a:t>
             </a:r>
           </a:p>
         </p:txBody>
@@ -3720,7 +3720,7 @@
                 </a:solidFill>
                 <a:latin typeface="Calibri"/>
               </a:rPr>
-              <a:t>Figure 5. Principal-component-based ICR in eight International Stroke Trial country groups: estimator values, their dispersion, and their relation to 14-day mortality.</a:t>
+              <a:t>Figure 4. Principal-component-based ICR in eight International Stroke Trial country groups: estimator values, their dispersion, and their relation to 14-day mortality.</a:t>
             </a:r>
           </a:p>
         </p:txBody>
@@ -3773,7 +3773,7 @@
                 </a:solidFill>
                 <a:latin typeface="Calibri"/>
               </a:rPr>
-              <a:t>Figure 6</a:t>
+              <a:t>Supplementary Figure S2</a:t>
             </a:r>
           </a:p>
         </p:txBody>
@@ -3832,7 +3832,7 @@
                 </a:solidFill>
                 <a:latin typeface="Calibri"/>
               </a:rPr>
-              <a:t>Figure 6. Leave-one-out recomputation of the association between each PCA-based ICR estimator and 14-day mortality across the eight country groups.</a:t>
+              <a:t>Supplementary Figure S2. Leave-one-out recomputation of the association between each PCA-based ICR estimator and 14-day mortality across the eight country groups.</a:t>
             </a:r>
           </a:p>
         </p:txBody>
@@ -3885,7 +3885,7 @@
                 </a:solidFill>
                 <a:latin typeface="Calibri"/>
               </a:rPr>
-              <a:t>Figure 7</a:t>
+              <a:t>Figure 5</a:t>
             </a:r>
           </a:p>
         </p:txBody>
@@ -3944,7 +3944,7 @@
                 </a:solidFill>
                 <a:latin typeface="Calibri"/>
               </a:rPr>
-              <a:t>Figure 7. Prism forest plot for the International Stroke Trial country groups, with colour encoding the loading-based estimator and marker size the regression-based estimator. Rates are shown for display; the groups are not independent trials.</a:t>
+              <a:t>Figure 5. Prism forest plot for the International Stroke Trial country groups, with colour encoding the loading-based estimator and marker size the regression-based estimator. Rates are shown for display; the groups are not independent trials.</a:t>
             </a:r>
           </a:p>
         </p:txBody>

</xml_diff>